<commit_message>
Refina entrega final de sueño y memoria
</commit_message>
<xml_diff>
--- a/deliverables/presentacion.pptx
+++ b/deliverables/presentacion.pptx
@@ -26,7 +26,7 @@
     <p:sldId id="274" r:id="rId25"/>
     <p:sldId id="275" r:id="rId26"/>
   </p:sldIdLst>
-  <p:sldSz cx="12191695" cy="6858000" type="screen4x3"/>
+  <p:sldSz cx="12191999" cy="6858000" type="screen4x3"/>
   <p:notesSz cx="6858000" cy="9144000"/>
   <p:defaultTextStyle>
     <a:defPPr>
@@ -3124,7 +3124,7 @@
         <p:spPr>
           <a:xfrm>
             <a:off x="0" y="0"/>
-            <a:ext cx="12191695" cy="6858000"/>
+            <a:ext cx="12191999" cy="6858000"/>
           </a:xfrm>
           <a:prstGeom prst="rect">
             <a:avLst/>
@@ -3166,7 +3166,7 @@
         <p:spPr>
           <a:xfrm>
             <a:off x="0" y="0"/>
-            <a:ext cx="12191695" cy="6858000"/>
+            <a:ext cx="12191999" cy="6858000"/>
           </a:xfrm>
           <a:prstGeom prst="rect">
             <a:avLst/>
@@ -3208,7 +3208,7 @@
         <p:spPr>
           <a:xfrm>
             <a:off x="0" y="0"/>
-            <a:ext cx="12191695" cy="6858000"/>
+            <a:ext cx="12191999" cy="6858000"/>
           </a:xfrm>
           <a:prstGeom prst="rect">
             <a:avLst/>
@@ -3250,7 +3250,7 @@
         <p:spPr>
           <a:xfrm>
             <a:off x="0" y="0"/>
-            <a:ext cx="12191695" cy="6858000"/>
+            <a:ext cx="12191999" cy="6858000"/>
           </a:xfrm>
           <a:prstGeom prst="rect">
             <a:avLst/>
@@ -3292,7 +3292,7 @@
         <p:spPr>
           <a:xfrm>
             <a:off x="0" y="0"/>
-            <a:ext cx="12191695" cy="6858000"/>
+            <a:ext cx="12191999" cy="6858000"/>
           </a:xfrm>
           <a:prstGeom prst="rect">
             <a:avLst/>
@@ -3334,7 +3334,7 @@
         <p:spPr>
           <a:xfrm>
             <a:off x="0" y="0"/>
-            <a:ext cx="12191695" cy="6858000"/>
+            <a:ext cx="12191999" cy="6858000"/>
           </a:xfrm>
           <a:prstGeom prst="rect">
             <a:avLst/>
@@ -3376,7 +3376,7 @@
         <p:spPr>
           <a:xfrm>
             <a:off x="0" y="0"/>
-            <a:ext cx="12191695" cy="6858000"/>
+            <a:ext cx="12191999" cy="6858000"/>
           </a:xfrm>
           <a:prstGeom prst="rect">
             <a:avLst/>
@@ -3418,7 +3418,7 @@
         <p:spPr>
           <a:xfrm>
             <a:off x="0" y="0"/>
-            <a:ext cx="12191695" cy="6858000"/>
+            <a:ext cx="12191999" cy="6858000"/>
           </a:xfrm>
           <a:prstGeom prst="rect">
             <a:avLst/>
@@ -3460,7 +3460,7 @@
         <p:spPr>
           <a:xfrm>
             <a:off x="0" y="0"/>
-            <a:ext cx="12191695" cy="6858000"/>
+            <a:ext cx="12191999" cy="6858000"/>
           </a:xfrm>
           <a:prstGeom prst="rect">
             <a:avLst/>
@@ -3502,7 +3502,7 @@
         <p:spPr>
           <a:xfrm>
             <a:off x="0" y="0"/>
-            <a:ext cx="12191695" cy="6858000"/>
+            <a:ext cx="12191999" cy="6858000"/>
           </a:xfrm>
           <a:prstGeom prst="rect">
             <a:avLst/>
@@ -3544,7 +3544,7 @@
         <p:spPr>
           <a:xfrm>
             <a:off x="0" y="0"/>
-            <a:ext cx="12191695" cy="6858000"/>
+            <a:ext cx="12191999" cy="6858000"/>
           </a:xfrm>
           <a:prstGeom prst="rect">
             <a:avLst/>
@@ -3586,7 +3586,7 @@
         <p:spPr>
           <a:xfrm>
             <a:off x="0" y="0"/>
-            <a:ext cx="12191695" cy="6858000"/>
+            <a:ext cx="12191999" cy="6858000"/>
           </a:xfrm>
           <a:prstGeom prst="rect">
             <a:avLst/>
@@ -3628,7 +3628,7 @@
         <p:spPr>
           <a:xfrm>
             <a:off x="0" y="0"/>
-            <a:ext cx="12191695" cy="6858000"/>
+            <a:ext cx="12191999" cy="6858000"/>
           </a:xfrm>
           <a:prstGeom prst="rect">
             <a:avLst/>
@@ -3670,7 +3670,7 @@
         <p:spPr>
           <a:xfrm>
             <a:off x="0" y="0"/>
-            <a:ext cx="12191695" cy="6858000"/>
+            <a:ext cx="12191999" cy="6858000"/>
           </a:xfrm>
           <a:prstGeom prst="rect">
             <a:avLst/>
@@ -3712,7 +3712,7 @@
         <p:spPr>
           <a:xfrm>
             <a:off x="0" y="0"/>
-            <a:ext cx="12191695" cy="6858000"/>
+            <a:ext cx="12191999" cy="6858000"/>
           </a:xfrm>
           <a:prstGeom prst="rect">
             <a:avLst/>
@@ -3754,7 +3754,7 @@
         <p:spPr>
           <a:xfrm>
             <a:off x="0" y="0"/>
-            <a:ext cx="12191695" cy="6858000"/>
+            <a:ext cx="12191999" cy="6858000"/>
           </a:xfrm>
           <a:prstGeom prst="rect">
             <a:avLst/>
@@ -3796,7 +3796,7 @@
         <p:spPr>
           <a:xfrm>
             <a:off x="0" y="0"/>
-            <a:ext cx="12191695" cy="6858000"/>
+            <a:ext cx="12191999" cy="6858000"/>
           </a:xfrm>
           <a:prstGeom prst="rect">
             <a:avLst/>
@@ -3838,7 +3838,7 @@
         <p:spPr>
           <a:xfrm>
             <a:off x="0" y="0"/>
-            <a:ext cx="12191695" cy="6858000"/>
+            <a:ext cx="12191999" cy="6858000"/>
           </a:xfrm>
           <a:prstGeom prst="rect">
             <a:avLst/>
@@ -3880,7 +3880,7 @@
         <p:spPr>
           <a:xfrm>
             <a:off x="0" y="0"/>
-            <a:ext cx="12191695" cy="6858000"/>
+            <a:ext cx="12191999" cy="6858000"/>
           </a:xfrm>
           <a:prstGeom prst="rect">
             <a:avLst/>
@@ -3922,7 +3922,7 @@
         <p:spPr>
           <a:xfrm>
             <a:off x="0" y="0"/>
-            <a:ext cx="12191695" cy="6858000"/>
+            <a:ext cx="12191999" cy="6858000"/>
           </a:xfrm>
           <a:prstGeom prst="rect">
             <a:avLst/>

</xml_diff>